<commit_message>
Correções da verificação de factos: relatório anual (primeiro em janeiro de 2029), alterações do registo (3 meses no art. 35.º, n.º 4), autoidentificação (60 dias após a plataforma), aprovação da SoA pela gestão
Também na jornada da aplicação e no guia ISO/IEC 27001.

Co-Authored-By: Claude Opus 5.5 <noreply@anthropic.com>
Claude-Session: https://claude.ai/code/session_011qfYtmLnj2mXUr5QojdZqn
</commit_message>
<xml_diff>
--- a/docs/onboarding/AnkoraOne-Apresentacao-Onboarding.pptx
+++ b/docs/onboarding/AnkoraOne-Apresentacao-Onboarding.pptx
@@ -126,7 +126,7 @@
   <p:extLst>
     <p:ext uri="{521415D9-36F7-43E2-AB2F-B90AF26B5E84}">
       <p14:sectionLst xmlns:p14="http://schemas.microsoft.com/office/powerpoint/2010/main">
-        <p14:section name="Abertura" id="{56759ea1-9d6e-0cf8-341e-464f77914f3c}">
+        <p14:section name="Abertura" id="{7799d756-8d4d-6123-205e-8b284313985f}">
           <p14:sldIdLst>
             <p14:sldId id="256"/>
             <p14:sldId id="257"/>
@@ -136,7 +136,7 @@
             <p14:sldId id="261"/>
           </p14:sldIdLst>
         </p14:section>
-        <p14:section name="Navegar e trabalhar" id="{70dc23ed-05cb-6673-c2d0-c6f78af92a72}">
+        <p14:section name="Navegar e trabalhar" id="{5965bf51-68b1-7bb9-8d5e-9bfe19719ba5}">
           <p14:sldIdLst>
             <p14:sldId id="262"/>
             <p14:sldId id="263"/>
@@ -147,7 +147,7 @@
             <p14:sldId id="268"/>
           </p14:sldIdLst>
         </p14:section>
-        <p14:section name="Guia por referencial" id="{cc85fff8-17fc-597f-eea7-85c6726640fd}">
+        <p14:section name="Guia por referencial" id="{9e1ca1e4-23cd-b549-267a-28c28de2b812}">
           <p14:sldIdLst>
             <p14:sldId id="269"/>
             <p14:sldId id="270"/>
@@ -156,7 +156,7 @@
             <p14:sldId id="273"/>
           </p14:sldIdLst>
         </p14:section>
-        <p14:section name="Fecho" id="{670e9f66-a7e8-afea-d7c6-e465fea43333}">
+        <p14:section name="Fecho" id="{836ef8ac-61ba-46e9-5de1-b1223c54bc9c}">
           <p14:sldIdLst>
             <p14:sldId id="274"/>
             <p14:sldId id="275"/>
@@ -8064,7 +8064,7 @@
                           <a:ea typeface="Calibri" pitchFamily="34" charset="-122"/>
                           <a:cs typeface="Calibri" pitchFamily="34" charset="-120"/>
                         </a:rPr>
-                        <a:t>Último dia útil de janeiro, a partir de 2028</a:t>
+                        <a:t>Último dia útil de janeiro; o primeiro em janeiro de 2029, relativo a 2028</a:t>
                       </a:r>
                       <a:endParaRPr lang="en-US" sz="1300" dirty="0">
                         <a:latin typeface="Calibri" charset="0"/>
@@ -14524,7 +14524,7 @@
                   <a:srgbClr val="111827"/>
                 </a:solidFill>
               </a:rPr>
-              <a:t>Tipo de entidade (art. 4.º)</a:t>
+              <a:t>Estabelecimento (art. 4.º)</a:t>
             </a:r>
             <a:endParaRPr lang="en-US" sz="1500" dirty="0"/>
           </a:p>

</xml_diff>

<commit_message>
Slogan da marca, cores no manifesto e setores e datas em português no painel
- Slogan principal «AnkoraOne: a infraestrutura inteligente de governação, risco e conformidade» na página de
  entrada, nos metadados da app, no README e nas capas do manual, dos guias, da apresentação de onboarding e dos
  modelos por referencial (gerados de novo).
- Manifesto e theme-color com o azul-escuro da marca (#070A13) em vez do azul por omissão.
- Painel: setor dos clientes traduzido e datas no formato da língua escolhida.

Co-Authored-By: Claude Opus 5.5 <noreply@anthropic.com>
Claude-Session: https://claude.ai/code/session_011qfYtmLnj2mXUr5QojdZqn
</commit_message>
<xml_diff>
--- a/docs/onboarding/AnkoraOne-Apresentacao-Onboarding.pptx
+++ b/docs/onboarding/AnkoraOne-Apresentacao-Onboarding.pptx
@@ -126,7 +126,7 @@
   <p:extLst>
     <p:ext uri="{521415D9-36F7-43E2-AB2F-B90AF26B5E84}">
       <p14:sectionLst xmlns:p14="http://schemas.microsoft.com/office/powerpoint/2010/main">
-        <p14:section name="Abertura" id="{7799d756-8d4d-6123-205e-8b284313985f}">
+        <p14:section name="Abertura" id="{4bdba960-c940-bedd-b8ff-65a0817df64c}">
           <p14:sldIdLst>
             <p14:sldId id="256"/>
             <p14:sldId id="257"/>
@@ -136,7 +136,7 @@
             <p14:sldId id="261"/>
           </p14:sldIdLst>
         </p14:section>
-        <p14:section name="Navegar e trabalhar" id="{5965bf51-68b1-7bb9-8d5e-9bfe19719ba5}">
+        <p14:section name="Navegar e trabalhar" id="{2a0ec043-9f62-6884-d72d-9323602e426e}">
           <p14:sldIdLst>
             <p14:sldId id="262"/>
             <p14:sldId id="263"/>
@@ -147,7 +147,7 @@
             <p14:sldId id="268"/>
           </p14:sldIdLst>
         </p14:section>
-        <p14:section name="Guia por referencial" id="{9e1ca1e4-23cd-b549-267a-28c28de2b812}">
+        <p14:section name="Guia por referencial" id="{b5d10f21-63c1-2877-7256-d7894a7ad04c}">
           <p14:sldIdLst>
             <p14:sldId id="269"/>
             <p14:sldId id="270"/>
@@ -156,7 +156,7 @@
             <p14:sldId id="273"/>
           </p14:sldIdLst>
         </p14:section>
-        <p14:section name="Fecho" id="{836ef8ac-61ba-46e9-5de1-b1223c54bc9c}">
+        <p14:section name="Fecho" id="{8c70fa58-36e7-c151-a1a0-6de7e719e8ec}">
           <p14:sldIdLst>
             <p14:sldId id="274"/>
             <p14:sldId id="275"/>
@@ -3300,6 +3300,53 @@
       <p:sp>
         <p:nvSpPr>
           <p:cNvPr id="5" name="Text 3"/>
+          <p:cNvSpPr txBox="1"/>
+          <p:nvPr/>
+        </p:nvSpPr>
+        <p:spPr>
+          <a:xfrm>
+            <a:off x="731520" y="5623560"/>
+            <a:ext cx="10058400" cy="320040"/>
+          </a:xfrm>
+          <a:prstGeom prst="rect">
+            <a:avLst/>
+          </a:prstGeom>
+          <a:noFill/>
+          <a:ln/>
+        </p:spPr>
+        <p:txBody>
+          <a:bodyPr wrap="square" lIns="0" tIns="0" rIns="0" bIns="0" rtlCol="0" anchor="t"/>
+          <a:lstStyle/>
+          <a:p>
+            <a:pPr indent="0" marL="0">
+              <a:buNone/>
+            </a:pPr>
+            <a:r>
+              <a:rPr lang="en-US" sz="1400" b="1" dirty="0">
+                <a:solidFill>
+                  <a:srgbClr val="CFA04A"/>
+                </a:solidFill>
+              </a:rPr>
+              <a:t>AnkoraOne: </a:t>
+            </a:r>
+            <a:pPr indent="0" marL="0">
+              <a:buNone/>
+            </a:pPr>
+            <a:r>
+              <a:rPr lang="en-US" sz="1400" dirty="0">
+                <a:solidFill>
+                  <a:srgbClr val="FFFFFF"/>
+                </a:solidFill>
+              </a:rPr>
+              <a:t>a infraestrutura inteligente de governação, risco e conformidade</a:t>
+            </a:r>
+            <a:endParaRPr lang="en-US" sz="1400" dirty="0"/>
+          </a:p>
+        </p:txBody>
+      </p:sp>
+      <p:sp>
+        <p:nvSpPr>
+          <p:cNvPr id="6" name="Text 4"/>
           <p:cNvSpPr txBox="1"/>
           <p:nvPr/>
         </p:nvSpPr>

</xml_diff>

<commit_message>
Slogan da marca, cores no manifesto e setores e datas em português no painel (#54)
- Slogan principal «AnkoraOne: a infraestrutura inteligente de governação, risco e conformidade» na página de
  entrada, nos metadados da app, no README e nas capas do manual, dos guias, da apresentação de onboarding e dos
  modelos por referencial (gerados de novo).
- Manifesto e theme-color com o azul-escuro da marca (#070A13) em vez do azul por omissão.
- Painel: setor dos clientes traduzido e datas no formato da língua escolhida.


Claude-Session: https://claude.ai/code/session_011qfYtmLnj2mXUr5QojdZqn

Co-authored-by: Claude <noreply@anthropic.com>
</commit_message>
<xml_diff>
--- a/docs/onboarding/AnkoraOne-Apresentacao-Onboarding.pptx
+++ b/docs/onboarding/AnkoraOne-Apresentacao-Onboarding.pptx
@@ -126,7 +126,7 @@
   <p:extLst>
     <p:ext uri="{521415D9-36F7-43E2-AB2F-B90AF26B5E84}">
       <p14:sectionLst xmlns:p14="http://schemas.microsoft.com/office/powerpoint/2010/main">
-        <p14:section name="Abertura" id="{7799d756-8d4d-6123-205e-8b284313985f}">
+        <p14:section name="Abertura" id="{4bdba960-c940-bedd-b8ff-65a0817df64c}">
           <p14:sldIdLst>
             <p14:sldId id="256"/>
             <p14:sldId id="257"/>
@@ -136,7 +136,7 @@
             <p14:sldId id="261"/>
           </p14:sldIdLst>
         </p14:section>
-        <p14:section name="Navegar e trabalhar" id="{5965bf51-68b1-7bb9-8d5e-9bfe19719ba5}">
+        <p14:section name="Navegar e trabalhar" id="{2a0ec043-9f62-6884-d72d-9323602e426e}">
           <p14:sldIdLst>
             <p14:sldId id="262"/>
             <p14:sldId id="263"/>
@@ -147,7 +147,7 @@
             <p14:sldId id="268"/>
           </p14:sldIdLst>
         </p14:section>
-        <p14:section name="Guia por referencial" id="{9e1ca1e4-23cd-b549-267a-28c28de2b812}">
+        <p14:section name="Guia por referencial" id="{b5d10f21-63c1-2877-7256-d7894a7ad04c}">
           <p14:sldIdLst>
             <p14:sldId id="269"/>
             <p14:sldId id="270"/>
@@ -156,7 +156,7 @@
             <p14:sldId id="273"/>
           </p14:sldIdLst>
         </p14:section>
-        <p14:section name="Fecho" id="{836ef8ac-61ba-46e9-5de1-b1223c54bc9c}">
+        <p14:section name="Fecho" id="{8c70fa58-36e7-c151-a1a0-6de7e719e8ec}">
           <p14:sldIdLst>
             <p14:sldId id="274"/>
             <p14:sldId id="275"/>
@@ -3300,6 +3300,53 @@
       <p:sp>
         <p:nvSpPr>
           <p:cNvPr id="5" name="Text 3"/>
+          <p:cNvSpPr txBox="1"/>
+          <p:nvPr/>
+        </p:nvSpPr>
+        <p:spPr>
+          <a:xfrm>
+            <a:off x="731520" y="5623560"/>
+            <a:ext cx="10058400" cy="320040"/>
+          </a:xfrm>
+          <a:prstGeom prst="rect">
+            <a:avLst/>
+          </a:prstGeom>
+          <a:noFill/>
+          <a:ln/>
+        </p:spPr>
+        <p:txBody>
+          <a:bodyPr wrap="square" lIns="0" tIns="0" rIns="0" bIns="0" rtlCol="0" anchor="t"/>
+          <a:lstStyle/>
+          <a:p>
+            <a:pPr indent="0" marL="0">
+              <a:buNone/>
+            </a:pPr>
+            <a:r>
+              <a:rPr lang="en-US" sz="1400" b="1" dirty="0">
+                <a:solidFill>
+                  <a:srgbClr val="CFA04A"/>
+                </a:solidFill>
+              </a:rPr>
+              <a:t>AnkoraOne: </a:t>
+            </a:r>
+            <a:pPr indent="0" marL="0">
+              <a:buNone/>
+            </a:pPr>
+            <a:r>
+              <a:rPr lang="en-US" sz="1400" dirty="0">
+                <a:solidFill>
+                  <a:srgbClr val="FFFFFF"/>
+                </a:solidFill>
+              </a:rPr>
+              <a:t>a infraestrutura inteligente de governação, risco e conformidade</a:t>
+            </a:r>
+            <a:endParaRPr lang="en-US" sz="1400" dirty="0"/>
+          </a:p>
+        </p:txBody>
+      </p:sp>
+      <p:sp>
+        <p:nvSpPr>
+          <p:cNvPr id="6" name="Text 4"/>
           <p:cNvSpPr txBox="1"/>
           <p:nvPr/>
         </p:nvSpPr>

</xml_diff>